<commit_message>
2026/09/11 : upload AWebWiz
</commit_message>
<xml_diff>
--- a/syllabus/23_architecture_MVC/syllabus_23_mvc.pptx
+++ b/syllabus/23_architecture_MVC/syllabus_23_mvc.pptx
@@ -9,7 +9,7 @@
   </p:notesMasterIdLst>
   <p:sldIdLst>
     <p:sldId id="416" r:id="rId2"/>
-    <p:sldId id="417" r:id="rId3"/>
+    <p:sldId id="650" r:id="rId3"/>
     <p:sldId id="302" r:id="rId4"/>
     <p:sldId id="622" r:id="rId5"/>
     <p:sldId id="534" r:id="rId6"/>
@@ -150,7 +150,7 @@
         <p14:section name="23. MVC" id="{BD2549DE-037A-41C0-9C31-899599FC6615}">
           <p14:sldIdLst>
             <p14:sldId id="416"/>
-            <p14:sldId id="417"/>
+            <p14:sldId id="650"/>
             <p14:sldId id="302"/>
             <p14:sldId id="622"/>
             <p14:sldId id="534"/>
@@ -5045,7 +5045,7 @@
           <a:p>
             <a:fld id="{FCE9742F-4DAE-47F5-9244-6ACC3985DD6B}" type="datetimeFigureOut">
               <a:rPr lang="fr-BE" smtClean="0"/>
-              <a:t>20-02-26</a:t>
+              <a:t>11-09-26</a:t>
             </a:fld>
             <a:endParaRPr lang="fr-BE"/>
           </a:p>
@@ -6285,7 +6285,7 @@
           <a:p>
             <a:fld id="{F3953782-D06E-4853-BE3C-64C197273937}" type="datetimeFigureOut">
               <a:rPr lang="fr-BE" smtClean="0"/>
-              <a:t>20-02-26</a:t>
+              <a:t>11-09-26</a:t>
             </a:fld>
             <a:endParaRPr lang="fr-BE"/>
           </a:p>
@@ -8153,7 +8153,7 @@
           <a:p>
             <a:fld id="{F3953782-D06E-4853-BE3C-64C197273937}" type="datetimeFigureOut">
               <a:rPr lang="fr-BE" smtClean="0"/>
-              <a:t>20-02-26</a:t>
+              <a:t>11-09-26</a:t>
             </a:fld>
             <a:endParaRPr lang="fr-BE"/>
           </a:p>
@@ -8469,7 +8469,7 @@
           <a:p>
             <a:fld id="{F3953782-D06E-4853-BE3C-64C197273937}" type="datetimeFigureOut">
               <a:rPr lang="fr-BE" smtClean="0"/>
-              <a:t>20-02-26</a:t>
+              <a:t>11-09-26</a:t>
             </a:fld>
             <a:endParaRPr lang="fr-BE"/>
           </a:p>
@@ -8666,7 +8666,7 @@
           <a:p>
             <a:fld id="{F3953782-D06E-4853-BE3C-64C197273937}" type="datetimeFigureOut">
               <a:rPr lang="fr-BE" smtClean="0"/>
-              <a:t>20-02-26</a:t>
+              <a:t>11-09-26</a:t>
             </a:fld>
             <a:endParaRPr lang="fr-BE"/>
           </a:p>
@@ -8928,7 +8928,7 @@
           <a:p>
             <a:fld id="{F3953782-D06E-4853-BE3C-64C197273937}" type="datetimeFigureOut">
               <a:rPr lang="fr-BE" smtClean="0"/>
-              <a:t>20-02-26</a:t>
+              <a:t>11-09-26</a:t>
             </a:fld>
             <a:endParaRPr lang="fr-BE"/>
           </a:p>
@@ -9326,7 +9326,7 @@
           <a:p>
             <a:fld id="{F3953782-D06E-4853-BE3C-64C197273937}" type="datetimeFigureOut">
               <a:rPr lang="fr-BE" smtClean="0"/>
-              <a:t>20-02-26</a:t>
+              <a:t>11-09-26</a:t>
             </a:fld>
             <a:endParaRPr lang="fr-BE"/>
           </a:p>
@@ -9474,7 +9474,7 @@
           <a:p>
             <a:fld id="{F3953782-D06E-4853-BE3C-64C197273937}" type="datetimeFigureOut">
               <a:rPr lang="fr-BE" smtClean="0"/>
-              <a:t>20-02-26</a:t>
+              <a:t>11-09-26</a:t>
             </a:fld>
             <a:endParaRPr lang="fr-BE"/>
           </a:p>
@@ -9823,7 +9823,7 @@
           <a:p>
             <a:fld id="{F3953782-D06E-4853-BE3C-64C197273937}" type="datetimeFigureOut">
               <a:rPr lang="fr-BE" smtClean="0"/>
-              <a:t>20-02-26</a:t>
+              <a:t>11-09-26</a:t>
             </a:fld>
             <a:endParaRPr lang="fr-BE"/>
           </a:p>
@@ -10149,7 +10149,7 @@
           <a:p>
             <a:fld id="{F3953782-D06E-4853-BE3C-64C197273937}" type="datetimeFigureOut">
               <a:rPr lang="fr-BE" smtClean="0"/>
-              <a:t>20-02-26</a:t>
+              <a:t>11-09-26</a:t>
             </a:fld>
             <a:endParaRPr lang="fr-BE"/>
           </a:p>
@@ -10800,7 +10800,7 @@
         <p14:reveal/>
       </p:transition>
     </mc:Choice>
-    <mc:Fallback xmlns="" xmlns:mv="urn:schemas-microsoft-com:mac:vml" xmlns:c="http://schemas.openxmlformats.org/drawingml/2006/chart" xmlns:dgm="http://schemas.openxmlformats.org/drawingml/2006/diagram" xmlns:o="urn:schemas-microsoft-com:office:office" xmlns:v="urn:schemas-microsoft-com:vml" xmlns:pvml="urn:schemas-microsoft-com:office:powerpoint" xmlns:com="http://schemas.openxmlformats.org/drawingml/2006/compatibility" xmlns:p15="http://schemas.microsoft.com/office/powerpoint/2012/main" xmlns:ahyp="http://schemas.microsoft.com/office/drawing/2018/hyperlinkcolor">
+    <mc:Fallback xmlns:ahyp="http://schemas.microsoft.com/office/drawing/2018/hyperlinkcolor" xmlns:p15="http://schemas.microsoft.com/office/powerpoint/2012/main" xmlns:com="http://schemas.openxmlformats.org/drawingml/2006/compatibility" xmlns:pvml="urn:schemas-microsoft-com:office:powerpoint" xmlns:v="urn:schemas-microsoft-com:vml" xmlns:o="urn:schemas-microsoft-com:office:office" xmlns:dgm="http://schemas.openxmlformats.org/drawingml/2006/diagram" xmlns:c="http://schemas.openxmlformats.org/drawingml/2006/chart" xmlns:mv="urn:schemas-microsoft-com:mac:vml" xmlns="">
       <p:transition spd="med">
         <p:fade/>
       </p:transition>
@@ -11512,19 +11512,19 @@
         </p:nvSpPr>
         <p:spPr>
           <a:xfrm>
-            <a:off x="0" y="0"/>
-            <a:ext cx="10515600" cy="6962775"/>
+            <a:off x="60960" y="137160"/>
+            <a:ext cx="11170920" cy="6374309"/>
           </a:xfrm>
         </p:spPr>
         <p:txBody>
-          <a:bodyPr numCol="1">
+          <a:bodyPr wrap="square" numCol="1">
             <a:spAutoFit/>
           </a:bodyPr>
           <a:lstStyle/>
           <a:p>
             <a:pPr>
               <a:lnSpc>
-                <a:spcPct val="100000"/>
+                <a:spcPts val="2400"/>
               </a:lnSpc>
               <a:buFont typeface="Garamond" panose="02020404030301010803" pitchFamily="18" charset="0"/>
               <a:buChar char="├"/>
@@ -11533,7 +11533,7 @@
               </a:tabLst>
             </a:pPr>
             <a:r>
-              <a:rPr lang="fr-BE" sz="2400" b="1">
+              <a:rPr lang="fr-BE" sz="2800" b="1">
                 <a:solidFill>
                   <a:schemeClr val="accent2"/>
                 </a:solidFill>
@@ -11541,20 +11541,20 @@
               <a:t>/</a:t>
             </a:r>
             <a:r>
-              <a:rPr lang="fr-BE" sz="2400"/>
+              <a:rPr lang="fr-BE" sz="2800"/>
               <a:t> : racine de l'application</a:t>
             </a:r>
           </a:p>
           <a:p>
             <a:pPr marL="1071563" lvl="1" indent="-342900">
               <a:lnSpc>
-                <a:spcPct val="100000"/>
+                <a:spcPts val="2400"/>
               </a:lnSpc>
               <a:buFont typeface="Garamond" panose="02020404030301010803" pitchFamily="18" charset="0"/>
               <a:buChar char="├"/>
             </a:pPr>
             <a:r>
-              <a:rPr lang="fr-BE" sz="2400" b="1">
+              <a:rPr lang="fr-BE" sz="2800" b="1">
                 <a:solidFill>
                   <a:schemeClr val="accent2"/>
                 </a:solidFill>
@@ -11562,10 +11562,10 @@
               <a:t>/app</a:t>
             </a:r>
             <a:r>
-              <a:rPr lang="fr-BE" sz="2400"/>
+              <a:rPr lang="fr-BE" sz="2800"/>
               <a:t> : code (PHP) de l'application</a:t>
             </a:r>
-            <a:endParaRPr lang="fr-BE" sz="2400" b="1">
+            <a:endParaRPr lang="fr-BE" sz="2800" b="1">
               <a:solidFill>
                 <a:schemeClr val="accent2"/>
               </a:solidFill>
@@ -11574,7 +11574,7 @@
           <a:p>
             <a:pPr marL="1800225" lvl="2" indent="-371475">
               <a:lnSpc>
-                <a:spcPct val="100000"/>
+                <a:spcPts val="2400"/>
               </a:lnSpc>
               <a:buFont typeface="Garamond" panose="02020404030301010803" pitchFamily="18" charset="0"/>
               <a:buChar char="├"/>
@@ -11583,7 +11583,7 @@
               </a:tabLst>
             </a:pPr>
             <a:r>
-              <a:rPr lang="fr-BE" sz="2400" b="1">
+              <a:rPr lang="fr-BE" b="1">
                 <a:solidFill>
                   <a:schemeClr val="accent2"/>
                 </a:solidFill>
@@ -11594,7 +11594,7 @@
           <a:p>
             <a:pPr marL="1800225" lvl="2" indent="-371475">
               <a:lnSpc>
-                <a:spcPct val="100000"/>
+                <a:spcPts val="2400"/>
               </a:lnSpc>
               <a:buFont typeface="Garamond" panose="02020404030301010803" pitchFamily="18" charset="0"/>
               <a:buChar char="├"/>
@@ -11603,7 +11603,7 @@
               </a:tabLst>
             </a:pPr>
             <a:r>
-              <a:rPr lang="fr-BE" sz="2400" b="1">
+              <a:rPr lang="fr-BE" b="1">
                 <a:solidFill>
                   <a:schemeClr val="accent2"/>
                 </a:solidFill>
@@ -11614,7 +11614,7 @@
           <a:p>
             <a:pPr marL="1800225" lvl="2" indent="-371475">
               <a:lnSpc>
-                <a:spcPct val="100000"/>
+                <a:spcPts val="2400"/>
               </a:lnSpc>
               <a:buFont typeface="Garamond" panose="02020404030301010803" pitchFamily="18" charset="0"/>
               <a:buChar char="├"/>
@@ -11623,7 +11623,7 @@
               </a:tabLst>
             </a:pPr>
             <a:r>
-              <a:rPr lang="fr-BE" sz="2400" b="1">
+              <a:rPr lang="fr-BE" b="1">
                 <a:solidFill>
                   <a:schemeClr val="accent2"/>
                 </a:solidFill>
@@ -11634,7 +11634,7 @@
           <a:p>
             <a:pPr marL="1800225" lvl="2" indent="-371475">
               <a:lnSpc>
-                <a:spcPct val="100000"/>
+                <a:spcPts val="2400"/>
               </a:lnSpc>
               <a:buFont typeface="Garamond" panose="02020404030301010803" pitchFamily="18" charset="0"/>
               <a:buChar char="├"/>
@@ -11643,11 +11643,11 @@
               </a:tabLst>
             </a:pPr>
             <a:r>
-              <a:rPr lang="fr-BE" sz="2400"/>
+              <a:rPr lang="fr-BE"/>
               <a:t>autres : </a:t>
             </a:r>
             <a:r>
-              <a:rPr lang="fr-BE" sz="2400" b="1">
+              <a:rPr lang="fr-BE" b="1">
                 <a:solidFill>
                   <a:schemeClr val="accent2"/>
                 </a:solidFill>
@@ -11655,10 +11655,10 @@
               <a:t>/helper, /config</a:t>
             </a:r>
             <a:r>
-              <a:rPr lang="fr-BE" sz="2400"/>
+              <a:rPr lang="fr-BE"/>
               <a:t>, …</a:t>
             </a:r>
-            <a:endParaRPr lang="fr-BE" sz="2400" b="1">
+            <a:endParaRPr lang="fr-BE" b="1">
               <a:solidFill>
                 <a:schemeClr val="accent2"/>
               </a:solidFill>
@@ -11667,7 +11667,7 @@
           <a:p>
             <a:pPr marL="1071563" lvl="1" indent="-342900">
               <a:lnSpc>
-                <a:spcPct val="100000"/>
+                <a:spcPts val="2400"/>
               </a:lnSpc>
               <a:buFont typeface="Garamond" panose="02020404030301010803" pitchFamily="18" charset="0"/>
               <a:buChar char="├"/>
@@ -11676,22 +11676,22 @@
               </a:tabLst>
             </a:pPr>
             <a:r>
-              <a:rPr lang="fr-BE" sz="2400" b="1">
+              <a:rPr lang="fr-BE" sz="2800" b="1">
                 <a:solidFill>
                   <a:schemeClr val="accent2"/>
                 </a:solidFill>
               </a:rPr>
-              <a:t>/asset</a:t>
-            </a:r>
-            <a:r>
-              <a:rPr lang="fr-BE" sz="2400"/>
+              <a:t>/assets</a:t>
+            </a:r>
+            <a:r>
+              <a:rPr lang="fr-BE" sz="2800"/>
               <a:t> : toute l'information privée</a:t>
             </a:r>
           </a:p>
           <a:p>
             <a:pPr marL="1801812" lvl="2" indent="-342900">
               <a:lnSpc>
-                <a:spcPct val="100000"/>
+                <a:spcPts val="2400"/>
               </a:lnSpc>
               <a:buFont typeface="Garamond" panose="02020404030301010803" pitchFamily="18" charset="0"/>
               <a:buChar char="├"/>
@@ -11700,7 +11700,7 @@
               </a:tabLst>
             </a:pPr>
             <a:r>
-              <a:rPr lang="fr-BE" sz="2400" b="1">
+              <a:rPr lang="fr-BE" b="1">
                 <a:solidFill>
                   <a:schemeClr val="accent2"/>
                 </a:solidFill>
@@ -11711,7 +11711,7 @@
           <a:p>
             <a:pPr marL="1801812" lvl="2" indent="-342900">
               <a:lnSpc>
-                <a:spcPct val="100000"/>
+                <a:spcPts val="2400"/>
               </a:lnSpc>
               <a:buFont typeface="Garamond" panose="02020404030301010803" pitchFamily="18" charset="0"/>
               <a:buChar char="├"/>
@@ -11720,18 +11720,31 @@
               </a:tabLst>
             </a:pPr>
             <a:r>
-              <a:rPr lang="fr-BE" sz="2400" b="1">
+              <a:rPr lang="fr-BE"/>
+              <a:t>autres : </a:t>
+            </a:r>
+            <a:r>
+              <a:rPr lang="fr-BE" b="1">
                 <a:solidFill>
                   <a:schemeClr val="accent2"/>
                 </a:solidFill>
               </a:rPr>
               <a:t>/static_content</a:t>
             </a:r>
+            <a:r>
+              <a:rPr lang="fr-BE"/>
+              <a:t>, …</a:t>
+            </a:r>
+            <a:endParaRPr lang="fr-BE" b="1">
+              <a:solidFill>
+                <a:schemeClr val="accent2"/>
+              </a:solidFill>
+            </a:endParaRPr>
           </a:p>
           <a:p>
             <a:pPr marL="1071563" lvl="1" indent="-342900">
               <a:lnSpc>
-                <a:spcPct val="100000"/>
+                <a:spcPts val="2400"/>
               </a:lnSpc>
               <a:buFont typeface="Garamond" panose="02020404030301010803" pitchFamily="18" charset="0"/>
               <a:buChar char="├"/>
@@ -11740,7 +11753,7 @@
               </a:tabLst>
             </a:pPr>
             <a:r>
-              <a:rPr lang="fr-BE" sz="2400" b="1">
+              <a:rPr lang="fr-BE" sz="2800" b="1">
                 <a:solidFill>
                   <a:schemeClr val="accent2"/>
                 </a:solidFill>
@@ -11748,14 +11761,14 @@
               <a:t>/public </a:t>
             </a:r>
             <a:r>
-              <a:rPr lang="fr-BE" sz="2400"/>
-              <a:t>: racine du site web</a:t>
+              <a:rPr lang="fr-BE" sz="2800"/>
+              <a:t>: racine du site web, l'information nécessaire au navigateur</a:t>
             </a:r>
           </a:p>
           <a:p>
             <a:pPr marL="1801812" lvl="2" indent="-342900">
               <a:lnSpc>
-                <a:spcPct val="100000"/>
+                <a:spcPts val="2400"/>
               </a:lnSpc>
               <a:buFont typeface="Garamond" panose="02020404030301010803" pitchFamily="18" charset="0"/>
               <a:buChar char="├"/>
@@ -11764,22 +11777,22 @@
               </a:tabLst>
             </a:pPr>
             <a:r>
-              <a:rPr lang="fr-BE" sz="2400" b="1">
+              <a:rPr lang="fr-BE" b="1">
                 <a:solidFill>
                   <a:schemeClr val="accent2"/>
                 </a:solidFill>
               </a:rPr>
-              <a:t>/css, /js </a:t>
-            </a:r>
-            <a:r>
-              <a:rPr lang="fr-BE" sz="2400"/>
-              <a:t>: l'information nécessaire au navigateur</a:t>
+              <a:t>/assets</a:t>
+            </a:r>
+            <a:r>
+              <a:rPr lang="fr-BE"/>
+              <a:t> : code de l'application </a:t>
             </a:r>
           </a:p>
           <a:p>
             <a:pPr marL="2259001" lvl="3" indent="-342900">
               <a:lnSpc>
-                <a:spcPct val="100000"/>
+                <a:spcPts val="2400"/>
               </a:lnSpc>
               <a:buFont typeface="Garamond" panose="02020404030301010803" pitchFamily="18" charset="0"/>
               <a:buChar char="├"/>
@@ -11788,22 +11801,27 @@
               </a:tabLst>
             </a:pPr>
             <a:r>
-              <a:rPr lang="fr-BE" b="1">
+              <a:rPr lang="fr-BE" sz="2800" b="1">
                 <a:solidFill>
                   <a:schemeClr val="accent2"/>
                 </a:solidFill>
               </a:rPr>
-              <a:t>internal</a:t>
-            </a:r>
-            <a:r>
-              <a:rPr lang="fr-BE"/>
-              <a:t> : développement interne </a:t>
-            </a:r>
+              <a:t>/components</a:t>
+            </a:r>
+            <a:r>
+              <a:rPr lang="fr-BE" sz="2800"/>
+              <a:t> : composants développés sous Vue.js </a:t>
+            </a:r>
+            <a:endParaRPr lang="fr-BE" sz="2800" b="1">
+              <a:solidFill>
+                <a:schemeClr val="accent2"/>
+              </a:solidFill>
+            </a:endParaRPr>
           </a:p>
           <a:p>
             <a:pPr marL="2259001" lvl="3" indent="-342900">
               <a:lnSpc>
-                <a:spcPct val="100000"/>
+                <a:spcPts val="2400"/>
               </a:lnSpc>
               <a:buFont typeface="Garamond" panose="02020404030301010803" pitchFamily="18" charset="0"/>
               <a:buChar char="├"/>
@@ -11812,22 +11830,18 @@
               </a:tabLst>
             </a:pPr>
             <a:r>
-              <a:rPr lang="fr-BE" b="1">
+              <a:rPr lang="fr-BE" sz="2800" b="1">
                 <a:solidFill>
                   <a:schemeClr val="accent2"/>
                 </a:solidFill>
               </a:rPr>
-              <a:t>bootstrap</a:t>
-            </a:r>
-            <a:r>
-              <a:rPr lang="fr-BE"/>
-              <a:t> : par exemple</a:t>
+              <a:t>/css, /js, /media </a:t>
             </a:r>
           </a:p>
           <a:p>
             <a:pPr marL="1801812" lvl="2" indent="-342900">
               <a:lnSpc>
-                <a:spcPct val="100000"/>
+                <a:spcPts val="2400"/>
               </a:lnSpc>
               <a:buFont typeface="Garamond" panose="02020404030301010803" pitchFamily="18" charset="0"/>
               <a:buChar char="├"/>
@@ -11836,27 +11850,22 @@
               </a:tabLst>
             </a:pPr>
             <a:r>
-              <a:rPr lang="fr-BE" sz="2400" b="1">
+              <a:rPr lang="fr-BE" b="1">
                 <a:solidFill>
                   <a:schemeClr val="accent2"/>
                 </a:solidFill>
               </a:rPr>
-              <a:t>/media</a:t>
-            </a:r>
-            <a:r>
-              <a:rPr lang="fr-BE" sz="2400"/>
-              <a:t> : matériel à destination de l'utilisateur (pdf, …)</a:t>
-            </a:r>
-            <a:endParaRPr lang="fr-BE" sz="2400" b="1">
-              <a:solidFill>
-                <a:schemeClr val="accent5"/>
-              </a:solidFill>
-            </a:endParaRPr>
-          </a:p>
-          <a:p>
-            <a:pPr marL="1801812" lvl="2" indent="-342900">
+              <a:t>/vendor</a:t>
+            </a:r>
+            <a:r>
+              <a:rPr lang="fr-BE"/>
+              <a:t> : packages externes </a:t>
+            </a:r>
+          </a:p>
+          <a:p>
+            <a:pPr marL="2259001" lvl="3" indent="-342900">
               <a:lnSpc>
-                <a:spcPct val="100000"/>
+                <a:spcPts val="2400"/>
               </a:lnSpc>
               <a:buFont typeface="Garamond" panose="02020404030301010803" pitchFamily="18" charset="0"/>
               <a:buChar char="├"/>
@@ -11865,27 +11874,22 @@
               </a:tabLst>
             </a:pPr>
             <a:r>
-              <a:rPr lang="fr-BE" sz="2400" b="1">
+              <a:rPr lang="fr-BE" sz="2800" b="1">
                 <a:solidFill>
                   <a:schemeClr val="accent2"/>
                 </a:solidFill>
               </a:rPr>
-              <a:t>index.php</a:t>
-            </a:r>
-            <a:r>
-              <a:rPr lang="fr-BE" sz="2400"/>
-              <a:t> : router</a:t>
-            </a:r>
-            <a:endParaRPr lang="fr-BE" sz="2400" b="1">
-              <a:solidFill>
-                <a:schemeClr val="accent2"/>
-              </a:solidFill>
-            </a:endParaRPr>
-          </a:p>
-          <a:p>
-            <a:pPr marL="1071563" lvl="1" indent="-342900">
+              <a:t>/bootstrap, /vuejs</a:t>
+            </a:r>
+            <a:r>
+              <a:rPr lang="fr-BE" sz="2800"/>
+              <a:t> : par exemple</a:t>
+            </a:r>
+          </a:p>
+          <a:p>
+            <a:pPr marL="1801812" lvl="2" indent="-342900">
               <a:lnSpc>
-                <a:spcPct val="100000"/>
+                <a:spcPts val="2400"/>
               </a:lnSpc>
               <a:buFont typeface="Garamond" panose="02020404030301010803" pitchFamily="18" charset="0"/>
               <a:buChar char="├"/>
@@ -11894,18 +11898,47 @@
               </a:tabLst>
             </a:pPr>
             <a:r>
-              <a:rPr lang="fr-BE" sz="2400" b="1">
+              <a:rPr lang="fr-BE" b="1">
                 <a:solidFill>
                   <a:schemeClr val="accent2"/>
                 </a:solidFill>
               </a:rPr>
-              <a:t>/external</a:t>
-            </a:r>
-            <a:r>
-              <a:rPr lang="fr-BE" sz="2400"/>
-              <a:t> : package externes</a:t>
-            </a:r>
-            <a:endParaRPr lang="fr-BE" sz="2400" b="1">
+              <a:t>index.php</a:t>
+            </a:r>
+            <a:r>
+              <a:rPr lang="fr-BE"/>
+              <a:t> : router</a:t>
+            </a:r>
+            <a:endParaRPr lang="fr-BE" b="1">
+              <a:solidFill>
+                <a:schemeClr val="accent2"/>
+              </a:solidFill>
+            </a:endParaRPr>
+          </a:p>
+          <a:p>
+            <a:pPr marL="1071563" lvl="1" indent="-342900">
+              <a:lnSpc>
+                <a:spcPts val="2400"/>
+              </a:lnSpc>
+              <a:buFont typeface="Garamond" panose="02020404030301010803" pitchFamily="18" charset="0"/>
+              <a:buChar char="├"/>
+              <a:tabLst>
+                <a:tab pos="1428750" algn="l"/>
+              </a:tabLst>
+            </a:pPr>
+            <a:r>
+              <a:rPr lang="fr-BE" sz="2800" b="1">
+                <a:solidFill>
+                  <a:schemeClr val="accent2"/>
+                </a:solidFill>
+              </a:rPr>
+              <a:t>/vendor</a:t>
+            </a:r>
+            <a:r>
+              <a:rPr lang="fr-BE" sz="2800"/>
+              <a:t> : packages externes </a:t>
+            </a:r>
+            <a:endParaRPr lang="fr-BE" sz="2800" b="1">
               <a:solidFill>
                 <a:schemeClr val="accent2"/>
               </a:solidFill>
@@ -12237,7 +12270,7 @@
                   <a:schemeClr val="accent2"/>
                 </a:solidFill>
               </a:rPr>
-              <a:t>/app/asset/database/</a:t>
+              <a:t>/app/assets/database/</a:t>
             </a:r>
             <a:r>
               <a:rPr lang="fr-BE" b="1" i="1">
@@ -12253,7 +12286,7 @@
                   <a:schemeClr val="accent2"/>
                 </a:solidFill>
               </a:rPr>
-              <a:t>.php</a:t>
+              <a:t>.csv</a:t>
             </a:r>
             <a:r>
               <a:rPr lang="fr-BE"/>
@@ -12459,14 +12492,14 @@
             <a:pPr marL="912812" lvl="1" indent="-457200"/>
             <a:r>
               <a:rPr lang="fr-BE"/>
-              <a:t>chacun contient une bibliothèque de fonctions PHP</a:t>
+              <a:t>chacun contient une classe et des méthodes PHP</a:t>
             </a:r>
           </a:p>
           <a:p>
             <a:pPr marL="912812" lvl="1" indent="-457200"/>
             <a:r>
               <a:rPr lang="fr-BE"/>
-              <a:t>ces fonctions gèrent l'accès et la manipulation de ces données</a:t>
+              <a:t>ces méthodes gèrent l'accès et la manipulation de ces données</a:t>
             </a:r>
             <a:endParaRPr lang="fr-BE" i="1"/>
           </a:p>
@@ -12485,14 +12518,14 @@
                   <a:schemeClr val="accent2"/>
                 </a:solidFill>
               </a:rPr>
-              <a:t>tout le code PHP est encapsulé dans des fonctions;</a:t>
+              <a:t>tout le code PHP est encapsulé dans des classes statiques;</a:t>
             </a:r>
           </a:p>
           <a:p>
             <a:pPr marL="992187" lvl="1" indent="-457200"/>
             <a:r>
               <a:rPr lang="fr-BE"/>
-              <a:t>on crée autant de fonctions que nécessaire;</a:t>
+              <a:t>on crée autant de méthodes que nécessaire;</a:t>
             </a:r>
           </a:p>
           <a:p>
@@ -12715,14 +12748,14 @@
             <a:pPr lvl="1"/>
             <a:r>
               <a:rPr lang="fr-BE"/>
-              <a:t>chacun contient une bibliothèque de fonctions PHP</a:t>
+              <a:t>chacun contient une classe et des méthodes PHP</a:t>
             </a:r>
           </a:p>
           <a:p>
             <a:pPr lvl="1"/>
             <a:r>
               <a:rPr lang="fr-BE"/>
-              <a:t>ces fonctions créent le code HTML du composant</a:t>
+              <a:t>ces méthodes créent le code HTML du composant</a:t>
             </a:r>
           </a:p>
           <a:p>
@@ -12739,14 +12772,14 @@
                   <a:schemeClr val="accent2"/>
                 </a:solidFill>
               </a:rPr>
-              <a:t>tout le code PHP est encapsulé dans des fonctions;</a:t>
+              <a:t>tout le code PHP est encapsulé dans des classes statiques;</a:t>
             </a:r>
           </a:p>
           <a:p>
             <a:pPr lvl="1"/>
             <a:r>
               <a:rPr lang="fr-BE"/>
-              <a:t>on crée autant de scripts que nécessaire;</a:t>
+              <a:t>on crée autant de méthodes que nécessaire;</a:t>
             </a:r>
           </a:p>
           <a:p>
@@ -12925,13 +12958,23 @@
             <p:ph idx="1"/>
           </p:nvPr>
         </p:nvSpPr>
-        <p:spPr/>
+        <p:spPr>
+          <a:xfrm>
+            <a:off x="838200" y="1690688"/>
+            <a:ext cx="10515600" cy="5167311"/>
+          </a:xfrm>
+        </p:spPr>
         <p:txBody>
           <a:bodyPr>
             <a:normAutofit fontScale="92500" lnSpcReduction="20000"/>
           </a:bodyPr>
           <a:lstStyle/>
           <a:p>
+            <a:pPr>
+              <a:lnSpc>
+                <a:spcPct val="110000"/>
+              </a:lnSpc>
+            </a:pPr>
             <a:r>
               <a:rPr lang="fr-BE"/>
               <a:t>Dans le répertoire "</a:t>
@@ -12952,7 +12995,11 @@
             </a:r>
           </a:p>
           <a:p>
-            <a:pPr lvl="1"/>
+            <a:pPr lvl="1">
+              <a:lnSpc>
+                <a:spcPct val="110000"/>
+              </a:lnSpc>
+            </a:pPr>
             <a:r>
               <a:rPr lang="fr-BE"/>
               <a:t>un fichier PHP par composant : </a:t>
@@ -12963,21 +13010,26 @@
             </a:r>
           </a:p>
           <a:p>
-            <a:pPr lvl="1"/>
-            <a:r>
-              <a:rPr lang="fr-BE"/>
-              <a:t>chacun contient une bibliothèque de fonctions PHP</a:t>
-            </a:r>
-          </a:p>
-          <a:p>
-            <a:pPr lvl="1"/>
-            <a:r>
-              <a:rPr lang="fr-BE"/>
-              <a:t>chacun contient obligatoirement une fonction d'entrée</a:t>
-            </a:r>
-          </a:p>
-          <a:p>
-            <a:pPr lvl="2"/>
+            <a:pPr lvl="1">
+              <a:lnSpc>
+                <a:spcPct val="110000"/>
+              </a:lnSpc>
+            </a:pPr>
+            <a:r>
+              <a:rPr lang="fr-BE"/>
+              <a:t>chacun contient une classe et des méthodes PHP</a:t>
+            </a:r>
+          </a:p>
+          <a:p>
+            <a:pPr lvl="1">
+              <a:lnSpc>
+                <a:spcPct val="110000"/>
+              </a:lnSpc>
+            </a:pPr>
+            <a:r>
+              <a:rPr lang="fr-BE"/>
+              <a:t>chaque classe contient obligatoirement une méthode d'entrée </a:t>
+            </a:r>
             <a:r>
               <a:rPr lang="fr-BE">
                 <a:solidFill>
@@ -12987,61 +13039,63 @@
                 </a:solidFill>
                 <a:latin typeface="Consolas" panose="020B0609020204030204" pitchFamily="49" charset="0"/>
               </a:rPr>
-              <a:t>main_&lt;composant&gt;()</a:t>
-            </a:r>
-            <a:r>
-              <a:rPr lang="fr-BE"/>
-              <a:t> :  </a:t>
-            </a:r>
-            <a:r>
-              <a:rPr lang="fr-BE" i="1">
-                <a:solidFill>
-                  <a:schemeClr val="accent6">
-                    <a:lumMod val="50000"/>
-                  </a:schemeClr>
-                </a:solidFill>
-                <a:latin typeface="Consolas" panose="020B0609020204030204" pitchFamily="49" charset="0"/>
-              </a:rPr>
-              <a:t>main_login(), main_home(), …</a:t>
-            </a:r>
-          </a:p>
-          <a:p>
-            <a:pPr lvl="1"/>
-            <a:r>
-              <a:rPr lang="fr-BE"/>
-              <a:t>ces fonctions gèrent la logique du composant</a:t>
-            </a:r>
-          </a:p>
-          <a:p>
-            <a:pPr lvl="2"/>
-            <a:r>
-              <a:rPr lang="fr-BE"/>
-              <a:t>interaction utilisateur : superglobals</a:t>
-            </a:r>
-          </a:p>
-          <a:p>
-            <a:pPr lvl="2"/>
-            <a:r>
-              <a:rPr lang="fr-BE"/>
-              <a:t>appel à MODEL : création ou lecture des données </a:t>
-            </a:r>
-          </a:p>
-          <a:p>
-            <a:pPr lvl="2"/>
-            <a:r>
-              <a:rPr lang="fr-BE"/>
-              <a:t>appel à VIEW : création des contenus HTML</a:t>
-            </a:r>
-          </a:p>
-          <a:p>
-            <a:pPr lvl="1"/>
-            <a:r>
-              <a:rPr lang="fr-BE"/>
-              <a:t>ces fonctions manipulent les superglobals : </a:t>
-            </a:r>
-          </a:p>
-          <a:p>
-            <a:pPr lvl="2"/>
+              <a:t>public static function main()</a:t>
+            </a:r>
+          </a:p>
+          <a:p>
+            <a:pPr lvl="1">
+              <a:lnSpc>
+                <a:spcPct val="110000"/>
+              </a:lnSpc>
+            </a:pPr>
+            <a:r>
+              <a:rPr lang="fr-BE"/>
+              <a:t>ces méthodes gèrent </a:t>
+            </a:r>
+          </a:p>
+          <a:p>
+            <a:pPr lvl="2">
+              <a:lnSpc>
+                <a:spcPct val="110000"/>
+              </a:lnSpc>
+            </a:pPr>
+            <a:r>
+              <a:rPr lang="fr-BE"/>
+              <a:t>la logique du composant</a:t>
+            </a:r>
+          </a:p>
+          <a:p>
+            <a:pPr lvl="2">
+              <a:lnSpc>
+                <a:spcPct val="110000"/>
+              </a:lnSpc>
+            </a:pPr>
+            <a:r>
+              <a:rPr lang="fr-BE"/>
+              <a:t>les appels à MODEL : création ou lecture des données </a:t>
+            </a:r>
+          </a:p>
+          <a:p>
+            <a:pPr lvl="2">
+              <a:lnSpc>
+                <a:spcPct val="110000"/>
+              </a:lnSpc>
+            </a:pPr>
+            <a:r>
+              <a:rPr lang="fr-BE"/>
+              <a:t>les appels à VIEW : création des contenus HTML</a:t>
+            </a:r>
+          </a:p>
+          <a:p>
+            <a:pPr lvl="2">
+              <a:lnSpc>
+                <a:spcPct val="110000"/>
+              </a:lnSpc>
+            </a:pPr>
+            <a:r>
+              <a:rPr lang="fr-BE"/>
+              <a:t>les superglobals :  </a:t>
+            </a:r>
             <a:r>
               <a:rPr lang="fr-BE">
                 <a:solidFill>
@@ -13051,11 +13105,18 @@
                 </a:solidFill>
                 <a:latin typeface="Consolas" panose="020B0609020204030204" pitchFamily="49" charset="0"/>
               </a:rPr>
-              <a:t>$_GET, $_POST, $_COOKIES, $_SESSION,</a:t>
-            </a:r>
-            <a:r>
-              <a:rPr lang="fr-BE"/>
-              <a:t> etc.</a:t>
+              <a:t>$_GET, $_POST, $_COOKIES, $_SESSION</a:t>
+            </a:r>
+          </a:p>
+          <a:p>
+            <a:pPr lvl="2">
+              <a:lnSpc>
+                <a:spcPct val="110000"/>
+              </a:lnSpc>
+            </a:pPr>
+            <a:r>
+              <a:rPr lang="fr-BE"/>
+              <a:t>la génération du code HTML (ou JSON) retourné </a:t>
             </a:r>
           </a:p>
         </p:txBody>
@@ -13224,14 +13285,14 @@
                   <a:schemeClr val="accent2"/>
                 </a:solidFill>
               </a:rPr>
-              <a:t>tout le code PHP est encapsulé dans des fonctions;</a:t>
+              <a:t>tout le code PHP est encapsulé dans des classes statiques;</a:t>
             </a:r>
           </a:p>
           <a:p>
             <a:pPr lvl="1"/>
             <a:r>
               <a:rPr lang="fr-BE"/>
-              <a:t>on crée autant de scripts que nécessaire;</a:t>
+              <a:t>on crée autant de méthodes que nécessaire;</a:t>
             </a:r>
           </a:p>
           <a:p>
@@ -13369,7 +13430,7 @@
                   </a:schemeClr>
                 </a:solidFill>
               </a:rPr>
-              <a:t>/asset</a:t>
+              <a:t>/assets</a:t>
             </a:r>
             <a:r>
               <a:rPr lang="fr-BE"/>
@@ -13413,7 +13474,7 @@
                   </a:schemeClr>
                 </a:solidFill>
               </a:rPr>
-              <a:t>/asset</a:t>
+              <a:t>/assets</a:t>
             </a:r>
             <a:r>
               <a:rPr lang="fr-BE"/>
@@ -13463,7 +13524,7 @@
             <a:pPr lvl="1"/>
             <a:r>
               <a:rPr lang="fr-BE"/>
-              <a:t>on crée autant de répertoires ou de scripts que nécessaire;</a:t>
+              <a:t>on crée autant de répertoires que nécessaire;</a:t>
             </a:r>
           </a:p>
           <a:p>
@@ -13575,6 +13636,10 @@
           </p:nvPr>
         </p:nvSpPr>
         <p:spPr>
+          <a:xfrm>
+            <a:off x="839788" y="365125"/>
+            <a:ext cx="10515600" cy="1325563"/>
+          </a:xfrm>
           <a:noFill/>
           <a:ln>
             <a:noFill/>
@@ -13605,6 +13670,10 @@
           </p:nvPr>
         </p:nvSpPr>
         <p:spPr>
+          <a:xfrm>
+            <a:off x="839788" y="1681163"/>
+            <a:ext cx="3420000" cy="676143"/>
+          </a:xfrm>
           <a:noFill/>
           <a:ln>
             <a:noFill/>
@@ -13640,7 +13709,12 @@
             <p:ph type="body" idx="2"/>
           </p:nvPr>
         </p:nvSpPr>
-        <p:spPr/>
+        <p:spPr>
+          <a:xfrm>
+            <a:off x="839788" y="2353338"/>
+            <a:ext cx="3419999" cy="3836325"/>
+          </a:xfrm>
+        </p:spPr>
         <p:txBody>
           <a:bodyPr>
             <a:normAutofit/>
@@ -13706,7 +13780,12 @@
             <p:ph type="body" idx="3"/>
           </p:nvPr>
         </p:nvSpPr>
-        <p:spPr/>
+        <p:spPr>
+          <a:xfrm>
+            <a:off x="4394864" y="1677195"/>
+            <a:ext cx="3420000" cy="676143"/>
+          </a:xfrm>
+        </p:spPr>
         <p:txBody>
           <a:bodyPr anchor="t"/>
           <a:lstStyle/>
@@ -13737,8 +13816,8 @@
         </p:nvSpPr>
         <p:spPr>
           <a:xfrm>
-            <a:off x="4105275" y="2501107"/>
-            <a:ext cx="3709587" cy="3684588"/>
+            <a:off x="4394863" y="2357306"/>
+            <a:ext cx="3419999" cy="3828389"/>
           </a:xfrm>
         </p:spPr>
         <p:txBody>
@@ -13827,7 +13906,12 @@
             <p:ph type="body" idx="10"/>
           </p:nvPr>
         </p:nvSpPr>
-        <p:spPr/>
+        <p:spPr>
+          <a:xfrm>
+            <a:off x="7949940" y="1690688"/>
+            <a:ext cx="3420000" cy="662650"/>
+          </a:xfrm>
+        </p:spPr>
         <p:txBody>
           <a:bodyPr anchor="t"/>
           <a:lstStyle/>
@@ -13855,10 +13939,15 @@
             <p:ph type="body" idx="11"/>
           </p:nvPr>
         </p:nvSpPr>
-        <p:spPr/>
+        <p:spPr>
+          <a:xfrm>
+            <a:off x="7949937" y="2377806"/>
+            <a:ext cx="3433923" cy="3836325"/>
+          </a:xfrm>
+        </p:spPr>
         <p:txBody>
           <a:bodyPr>
-            <a:normAutofit/>
+            <a:normAutofit lnSpcReduction="10000"/>
           </a:bodyPr>
           <a:lstStyle/>
           <a:p>
@@ -13911,12 +14000,24 @@
             </a:r>
           </a:p>
           <a:p>
+            <a:pPr marL="114300" lvl="0" indent="0">
+              <a:buNone/>
+            </a:pPr>
+            <a:endParaRPr lang="fr-BE" sz="2400"/>
+          </a:p>
+          <a:p>
+            <a:pPr marL="114300" lvl="0" indent="0">
+              <a:buNone/>
+            </a:pPr>
+            <a:endParaRPr lang="fr-BE" sz="2400"/>
+          </a:p>
+          <a:p>
             <a:pPr marL="114300" indent="0">
               <a:buNone/>
             </a:pPr>
             <a:r>
               <a:rPr lang="fr-BE" sz="2400"/>
-              <a:t>27. Requête asynchrone</a:t>
+              <a:t>31. Requête asynchrone</a:t>
             </a:r>
           </a:p>
           <a:p>
@@ -13924,6 +14025,272 @@
               <a:buNone/>
             </a:pPr>
             <a:endParaRPr lang="fr-BE" sz="2400"/>
+          </a:p>
+        </p:txBody>
+      </p:sp>
+      <p:sp>
+        <p:nvSpPr>
+          <p:cNvPr id="5" name="Espace réservé du texte 9">
+            <a:extLst>
+              <a:ext uri="{FF2B5EF4-FFF2-40B4-BE49-F238E27FC236}">
+                <a16:creationId xmlns:a16="http://schemas.microsoft.com/office/drawing/2014/main" id="{F7F80AB2-1A54-F3C7-63AD-635689291298}"/>
+              </a:ext>
+            </a:extLst>
+          </p:cNvPr>
+          <p:cNvSpPr txBox="1">
+            <a:spLocks/>
+          </p:cNvSpPr>
+          <p:nvPr/>
+        </p:nvSpPr>
+        <p:spPr>
+          <a:xfrm>
+            <a:off x="7932738" y="5026572"/>
+            <a:ext cx="3751261" cy="823912"/>
+          </a:xfrm>
+          <a:prstGeom prst="rect">
+            <a:avLst/>
+          </a:prstGeom>
+          <a:noFill/>
+          <a:ln>
+            <a:noFill/>
+          </a:ln>
+        </p:spPr>
+        <p:txBody>
+          <a:bodyPr spcFirstLastPara="1" vert="horz" wrap="square" lIns="91425" tIns="45700" rIns="91425" bIns="45700" rtlCol="0" anchor="t" anchorCtr="0">
+            <a:normAutofit/>
+          </a:bodyPr>
+          <a:lstStyle>
+            <a:lvl1pPr marL="457200" lvl="0" indent="-228600" algn="l" defTabSz="914377" rtl="0" eaLnBrk="1" latinLnBrk="0" hangingPunct="1">
+              <a:lnSpc>
+                <a:spcPct val="90000"/>
+              </a:lnSpc>
+              <a:spcBef>
+                <a:spcPts val="1000"/>
+              </a:spcBef>
+              <a:spcAft>
+                <a:spcPts val="0"/>
+              </a:spcAft>
+              <a:buClr>
+                <a:schemeClr val="dk1"/>
+              </a:buClr>
+              <a:buSzPts val="2400"/>
+              <a:buFont typeface="Wingdings" panose="05000000000000000000" pitchFamily="2" charset="2"/>
+              <a:buNone/>
+              <a:defRPr sz="2400" b="1" kern="1200">
+                <a:solidFill>
+                  <a:schemeClr val="tx1"/>
+                </a:solidFill>
+                <a:latin typeface="+mn-lt"/>
+                <a:ea typeface="+mn-ea"/>
+                <a:cs typeface="+mn-cs"/>
+              </a:defRPr>
+            </a:lvl1pPr>
+            <a:lvl2pPr marL="914400" lvl="1" indent="-228600" algn="l" defTabSz="914377" rtl="0" eaLnBrk="1" latinLnBrk="0" hangingPunct="1">
+              <a:lnSpc>
+                <a:spcPct val="90000"/>
+              </a:lnSpc>
+              <a:spcBef>
+                <a:spcPts val="500"/>
+              </a:spcBef>
+              <a:spcAft>
+                <a:spcPts val="0"/>
+              </a:spcAft>
+              <a:buClr>
+                <a:schemeClr val="dk1"/>
+              </a:buClr>
+              <a:buSzPts val="2000"/>
+              <a:buFont typeface="Wingdings" panose="05000000000000000000" pitchFamily="2" charset="2"/>
+              <a:buNone/>
+              <a:defRPr sz="2000" b="1" kern="1200">
+                <a:solidFill>
+                  <a:schemeClr val="tx1"/>
+                </a:solidFill>
+                <a:latin typeface="+mn-lt"/>
+                <a:ea typeface="+mn-ea"/>
+                <a:cs typeface="+mn-cs"/>
+              </a:defRPr>
+            </a:lvl2pPr>
+            <a:lvl3pPr marL="1371600" lvl="2" indent="-228600" algn="l" defTabSz="914377" rtl="0" eaLnBrk="1" latinLnBrk="0" hangingPunct="1">
+              <a:lnSpc>
+                <a:spcPct val="90000"/>
+              </a:lnSpc>
+              <a:spcBef>
+                <a:spcPts val="500"/>
+              </a:spcBef>
+              <a:spcAft>
+                <a:spcPts val="0"/>
+              </a:spcAft>
+              <a:buClr>
+                <a:schemeClr val="dk1"/>
+              </a:buClr>
+              <a:buSzPts val="1800"/>
+              <a:buFont typeface="Wingdings" panose="05000000000000000000" pitchFamily="2" charset="2"/>
+              <a:buNone/>
+              <a:defRPr sz="1800" b="1" kern="1200">
+                <a:solidFill>
+                  <a:schemeClr val="tx1"/>
+                </a:solidFill>
+                <a:latin typeface="+mn-lt"/>
+                <a:ea typeface="+mn-ea"/>
+                <a:cs typeface="+mn-cs"/>
+              </a:defRPr>
+            </a:lvl3pPr>
+            <a:lvl4pPr marL="1828800" lvl="3" indent="-228600" algn="l" defTabSz="914377" rtl="0" eaLnBrk="1" latinLnBrk="0" hangingPunct="1">
+              <a:lnSpc>
+                <a:spcPct val="90000"/>
+              </a:lnSpc>
+              <a:spcBef>
+                <a:spcPts val="500"/>
+              </a:spcBef>
+              <a:spcAft>
+                <a:spcPts val="0"/>
+              </a:spcAft>
+              <a:buClr>
+                <a:schemeClr val="dk1"/>
+              </a:buClr>
+              <a:buSzPts val="1600"/>
+              <a:buFont typeface="Wingdings" panose="05000000000000000000" pitchFamily="2" charset="2"/>
+              <a:buNone/>
+              <a:defRPr sz="1600" b="1" kern="1200">
+                <a:solidFill>
+                  <a:schemeClr val="tx1"/>
+                </a:solidFill>
+                <a:latin typeface="+mn-lt"/>
+                <a:ea typeface="+mn-ea"/>
+                <a:cs typeface="+mn-cs"/>
+              </a:defRPr>
+            </a:lvl4pPr>
+            <a:lvl5pPr marL="2286000" lvl="4" indent="-228600" algn="l" defTabSz="914377" rtl="0" eaLnBrk="1" latinLnBrk="0" hangingPunct="1">
+              <a:lnSpc>
+                <a:spcPct val="90000"/>
+              </a:lnSpc>
+              <a:spcBef>
+                <a:spcPts val="500"/>
+              </a:spcBef>
+              <a:spcAft>
+                <a:spcPts val="0"/>
+              </a:spcAft>
+              <a:buClr>
+                <a:schemeClr val="dk1"/>
+              </a:buClr>
+              <a:buSzPts val="1600"/>
+              <a:buFont typeface="Wingdings" panose="05000000000000000000" pitchFamily="2" charset="2"/>
+              <a:buNone/>
+              <a:defRPr sz="1600" b="1" kern="1200">
+                <a:solidFill>
+                  <a:schemeClr val="tx1"/>
+                </a:solidFill>
+                <a:latin typeface="+mn-lt"/>
+                <a:ea typeface="+mn-ea"/>
+                <a:cs typeface="+mn-cs"/>
+              </a:defRPr>
+            </a:lvl5pPr>
+            <a:lvl6pPr marL="2743200" lvl="5" indent="-228600" algn="l" defTabSz="914377" rtl="0" eaLnBrk="1" latinLnBrk="0" hangingPunct="1">
+              <a:lnSpc>
+                <a:spcPct val="90000"/>
+              </a:lnSpc>
+              <a:spcBef>
+                <a:spcPts val="500"/>
+              </a:spcBef>
+              <a:spcAft>
+                <a:spcPts val="0"/>
+              </a:spcAft>
+              <a:buClr>
+                <a:schemeClr val="dk1"/>
+              </a:buClr>
+              <a:buSzPts val="1600"/>
+              <a:buFont typeface="Arial" panose="020B0604020202020204" pitchFamily="34" charset="0"/>
+              <a:buNone/>
+              <a:defRPr sz="1600" b="1" kern="1200">
+                <a:solidFill>
+                  <a:schemeClr val="tx1"/>
+                </a:solidFill>
+                <a:latin typeface="+mn-lt"/>
+                <a:ea typeface="+mn-ea"/>
+                <a:cs typeface="+mn-cs"/>
+              </a:defRPr>
+            </a:lvl6pPr>
+            <a:lvl7pPr marL="3200400" lvl="6" indent="-228600" algn="l" defTabSz="914377" rtl="0" eaLnBrk="1" latinLnBrk="0" hangingPunct="1">
+              <a:lnSpc>
+                <a:spcPct val="90000"/>
+              </a:lnSpc>
+              <a:spcBef>
+                <a:spcPts val="500"/>
+              </a:spcBef>
+              <a:spcAft>
+                <a:spcPts val="0"/>
+              </a:spcAft>
+              <a:buClr>
+                <a:schemeClr val="dk1"/>
+              </a:buClr>
+              <a:buSzPts val="1600"/>
+              <a:buFont typeface="Arial" panose="020B0604020202020204" pitchFamily="34" charset="0"/>
+              <a:buNone/>
+              <a:defRPr sz="1600" b="1" kern="1200">
+                <a:solidFill>
+                  <a:schemeClr val="tx1"/>
+                </a:solidFill>
+                <a:latin typeface="+mn-lt"/>
+                <a:ea typeface="+mn-ea"/>
+                <a:cs typeface="+mn-cs"/>
+              </a:defRPr>
+            </a:lvl7pPr>
+            <a:lvl8pPr marL="3657600" lvl="7" indent="-228600" algn="l" defTabSz="914377" rtl="0" eaLnBrk="1" latinLnBrk="0" hangingPunct="1">
+              <a:lnSpc>
+                <a:spcPct val="90000"/>
+              </a:lnSpc>
+              <a:spcBef>
+                <a:spcPts val="500"/>
+              </a:spcBef>
+              <a:spcAft>
+                <a:spcPts val="0"/>
+              </a:spcAft>
+              <a:buClr>
+                <a:schemeClr val="dk1"/>
+              </a:buClr>
+              <a:buSzPts val="1600"/>
+              <a:buFont typeface="Arial" panose="020B0604020202020204" pitchFamily="34" charset="0"/>
+              <a:buNone/>
+              <a:defRPr sz="1600" b="1" kern="1200">
+                <a:solidFill>
+                  <a:schemeClr val="tx1"/>
+                </a:solidFill>
+                <a:latin typeface="+mn-lt"/>
+                <a:ea typeface="+mn-ea"/>
+                <a:cs typeface="+mn-cs"/>
+              </a:defRPr>
+            </a:lvl8pPr>
+            <a:lvl9pPr marL="4114800" lvl="8" indent="-228600" algn="l" defTabSz="914377" rtl="0" eaLnBrk="1" latinLnBrk="0" hangingPunct="1">
+              <a:lnSpc>
+                <a:spcPct val="90000"/>
+              </a:lnSpc>
+              <a:spcBef>
+                <a:spcPts val="500"/>
+              </a:spcBef>
+              <a:spcAft>
+                <a:spcPts val="0"/>
+              </a:spcAft>
+              <a:buClr>
+                <a:schemeClr val="dk1"/>
+              </a:buClr>
+              <a:buSzPts val="1600"/>
+              <a:buFont typeface="Arial" panose="020B0604020202020204" pitchFamily="34" charset="0"/>
+              <a:buNone/>
+              <a:defRPr sz="1600" b="1" kern="1200">
+                <a:solidFill>
+                  <a:schemeClr val="tx1"/>
+                </a:solidFill>
+                <a:latin typeface="+mn-lt"/>
+                <a:ea typeface="+mn-ea"/>
+                <a:cs typeface="+mn-cs"/>
+              </a:defRPr>
+            </a:lvl9pPr>
+          </a:lstStyle>
+          <a:p>
+            <a:r>
+              <a:rPr lang="fr-BE"/>
+              <a:t>Single Page Application</a:t>
+            </a:r>
           </a:p>
         </p:txBody>
       </p:sp>
@@ -14019,10 +14386,15 @@
             <p:ph idx="1"/>
           </p:nvPr>
         </p:nvSpPr>
-        <p:spPr/>
+        <p:spPr>
+          <a:xfrm>
+            <a:off x="838200" y="1690688"/>
+            <a:ext cx="10515600" cy="5167311"/>
+          </a:xfrm>
+        </p:spPr>
         <p:txBody>
           <a:bodyPr>
-            <a:normAutofit fontScale="92500" lnSpcReduction="20000"/>
+            <a:normAutofit fontScale="85000" lnSpcReduction="20000"/>
           </a:bodyPr>
           <a:lstStyle/>
           <a:p>
@@ -14072,24 +14444,35 @@
                   <a:schemeClr val="accent2"/>
                 </a:solidFill>
               </a:rPr>
+              <a:t>/assets </a:t>
+            </a:r>
+          </a:p>
+          <a:p>
+            <a:pPr marL="1370000" lvl="2" indent="-457200"/>
+            <a:r>
+              <a:rPr lang="fr-BE"/>
+              <a:t>information propre à l'application</a:t>
+            </a:r>
+          </a:p>
+          <a:p>
+            <a:pPr marL="1370000" lvl="2" indent="-457200"/>
+            <a:r>
+              <a:rPr lang="fr-BE" b="1">
+                <a:solidFill>
+                  <a:schemeClr val="accent2"/>
+                </a:solidFill>
+              </a:rPr>
               <a:t>/media</a:t>
             </a:r>
             <a:r>
               <a:rPr lang="fr-BE"/>
-              <a:t> : images et documents généraux du site</a:t>
-            </a:r>
-          </a:p>
-          <a:p>
-            <a:pPr marL="1255700" lvl="2" indent="-342900"/>
-            <a:r>
-              <a:rPr lang="fr-BE"/>
-              <a:t>logo, fond de pages, illustrations, icônes, conditions générales, rapport annuel, …</a:t>
-            </a:r>
-          </a:p>
-          <a:p>
-            <a:pPr marL="912812" lvl="1" indent="-457200"/>
-            <a:r>
-              <a:rPr lang="fr-BE" sz="3000" b="1">
+              <a:t> : images et documents généraux du site (logo, icônes, …)</a:t>
+            </a:r>
+          </a:p>
+          <a:p>
+            <a:pPr marL="1370000" lvl="2" indent="-457200"/>
+            <a:r>
+              <a:rPr lang="fr-BE" b="1">
                 <a:solidFill>
                   <a:schemeClr val="accent2"/>
                 </a:solidFill>
@@ -14102,7 +14485,7 @@
             </a:r>
           </a:p>
           <a:p>
-            <a:pPr marL="912812" lvl="1" indent="-457200"/>
+            <a:pPr marL="1370000" lvl="2" indent="-457200"/>
             <a:r>
               <a:rPr lang="fr-BE" b="1">
                 <a:solidFill>
@@ -14117,6 +14500,31 @@
             </a:r>
           </a:p>
           <a:p>
+            <a:pPr marL="912812" lvl="1" indent="-457200"/>
+            <a:r>
+              <a:rPr lang="fr-BE" b="1">
+                <a:solidFill>
+                  <a:schemeClr val="accent2"/>
+                </a:solidFill>
+              </a:rPr>
+              <a:t>/vendor</a:t>
+            </a:r>
+          </a:p>
+          <a:p>
+            <a:pPr marL="1370000" lvl="2" indent="-457200"/>
+            <a:r>
+              <a:rPr lang="fr-BE"/>
+              <a:t>packages importés </a:t>
+            </a:r>
+          </a:p>
+          <a:p>
+            <a:pPr marL="1370000" lvl="2" indent="-457200"/>
+            <a:r>
+              <a:rPr lang="fr-BE"/>
+              <a:t>un répertoire par package</a:t>
+            </a:r>
+          </a:p>
+          <a:p>
             <a:r>
               <a:rPr lang="fr-BE"/>
               <a:t>Remarques : </a:t>
@@ -14126,7 +14534,7 @@
             <a:pPr lvl="1"/>
             <a:r>
               <a:rPr lang="fr-BE"/>
-              <a:t>on crée autant de répertoires ou de scripts que nécessaire;</a:t>
+              <a:t>on crée autant de répertoires que nécessaire;</a:t>
             </a:r>
           </a:p>
           <a:p>
@@ -14374,7 +14782,7 @@
             <a:pPr lvl="1"/>
             <a:r>
               <a:rPr lang="fr-BE"/>
-              <a:t>Appeler le Controller  de ce composant </a:t>
+              <a:t>Appeler Controller  de ce composant </a:t>
             </a:r>
           </a:p>
           <a:p>
@@ -16595,7 +17003,7 @@
         <p14:reveal/>
       </p:transition>
     </mc:Choice>
-    <mc:Fallback xmlns="" xmlns:mv="urn:schemas-microsoft-com:mac:vml" xmlns:c="http://schemas.openxmlformats.org/drawingml/2006/chart" xmlns:dgm="http://schemas.openxmlformats.org/drawingml/2006/diagram" xmlns:o="urn:schemas-microsoft-com:office:office" xmlns:v="urn:schemas-microsoft-com:vml" xmlns:pvml="urn:schemas-microsoft-com:office:powerpoint" xmlns:com="http://schemas.openxmlformats.org/drawingml/2006/compatibility" xmlns:p15="http://schemas.microsoft.com/office/powerpoint/2012/main" xmlns:ahyp="http://schemas.microsoft.com/office/drawing/2018/hyperlinkcolor">
+    <mc:Fallback xmlns:ahyp="http://schemas.microsoft.com/office/drawing/2018/hyperlinkcolor" xmlns:p15="http://schemas.microsoft.com/office/powerpoint/2012/main" xmlns:com="http://schemas.openxmlformats.org/drawingml/2006/compatibility" xmlns:pvml="urn:schemas-microsoft-com:office:powerpoint" xmlns:v="urn:schemas-microsoft-com:vml" xmlns:o="urn:schemas-microsoft-com:office:office" xmlns:dgm="http://schemas.openxmlformats.org/drawingml/2006/diagram" xmlns:c="http://schemas.openxmlformats.org/drawingml/2006/chart" xmlns:mv="urn:schemas-microsoft-com:mac:vml" xmlns="">
       <p:transition spd="med">
         <p:fade/>
       </p:transition>

</xml_diff>